<commit_message>
docs: drop DMRV-based initiative from WB state proposal
DMRV is positioned for the central BEE carbon-market onboarding and
registry flow, not as a state-department product. Remove the Sabuj
Shilpa initiative and its sources, rework the portfolio summary and
starting points around five initiatives, and replace the named DMRV
product on the goals slide with a general product/platform goal plus
an industry IoT data-logging services line.

Co-Authored-By: Claude Opus 5.5 <noreply@anthropic.com>
Claude-Session: https://claude.ai/code/session_01KWMWvQ91DXYjjkruj1UFSM
</commit_message>
<xml_diff>
--- a/docs/wb-ice-proposal-2026/Company_Vision_Goals.pptx
+++ b/docs/wb-ice-proposal-2026/Company_Vision_Goals.pptx
@@ -2798,11 +2798,11 @@
         <p:spPr>
           <a:xfrm>
             <a:off x="548640" y="2468880"/>
-            <a:ext cx="3566160" cy="2971800"/>
+            <a:ext cx="3566160" cy="3200400"/>
           </a:xfrm>
           <a:prstGeom prst="roundRect">
             <a:avLst>
-              <a:gd name="adj" fmla="val 3077"/>
+              <a:gd name="adj" fmla="val 2857"/>
             </a:avLst>
           </a:prstGeom>
           <a:solidFill>
@@ -2853,7 +2853,7 @@
                 <a:ea typeface="Calibri" pitchFamily="34" charset="-122"/>
                 <a:cs typeface="Calibri" pitchFamily="34" charset="-120"/>
               </a:rPr>
-              <a:t>1–2 paid pilots with the ICE Department (Karma Praman, Sabuj Shilpa)</a:t>
+              <a:t>1–2 paid pilots with the ICE Department (e.g. Karma Praman, Nivesh Setu)</a:t>
             </a:r>
             <a:endParaRPr lang="en-US" sz="1400" dirty="0"/>
           </a:p>
@@ -2909,7 +2909,7 @@
         </p:nvSpPr>
         <p:spPr>
           <a:xfrm>
-            <a:off x="777240" y="4709160"/>
+            <a:off x="777240" y="4937760"/>
             <a:ext cx="3108960" cy="548640"/>
           </a:xfrm>
           <a:prstGeom prst="roundRect">
@@ -2936,7 +2936,7 @@
         </p:nvSpPr>
         <p:spPr>
           <a:xfrm>
-            <a:off x="777240" y="4709160"/>
+            <a:off x="777240" y="4937760"/>
             <a:ext cx="3108960" cy="548640"/>
           </a:xfrm>
           <a:prstGeom prst="rect">
@@ -3118,11 +3118,11 @@
         <p:spPr>
           <a:xfrm>
             <a:off x="4407408" y="2468880"/>
-            <a:ext cx="3566160" cy="2971800"/>
+            <a:ext cx="3566160" cy="3200400"/>
           </a:xfrm>
           <a:prstGeom prst="roundRect">
             <a:avLst>
-              <a:gd name="adj" fmla="val 3077"/>
+              <a:gd name="adj" fmla="val 2857"/>
             </a:avLst>
           </a:prstGeom>
           <a:solidFill>
@@ -3194,7 +3194,7 @@
                 <a:ea typeface="Calibri" pitchFamily="34" charset="-122"/>
                 <a:cs typeface="Calibri" pitchFamily="34" charset="-120"/>
               </a:rPr>
-              <a:t>Private IT for Bengal industry: carbon and CBAM compliance, MSME automation</a:t>
+              <a:t>Industry services: IoT metering and data logging to central portals; MSME automation</a:t>
             </a:r>
             <a:endParaRPr lang="en-US" sz="1400" dirty="0"/>
           </a:p>
@@ -3229,7 +3229,7 @@
         </p:nvSpPr>
         <p:spPr>
           <a:xfrm>
-            <a:off x="4636008" y="4709160"/>
+            <a:off x="4636008" y="4937760"/>
             <a:ext cx="3108960" cy="548640"/>
           </a:xfrm>
           <a:prstGeom prst="roundRect">
@@ -3256,7 +3256,7 @@
         </p:nvSpPr>
         <p:spPr>
           <a:xfrm>
-            <a:off x="4636008" y="4709160"/>
+            <a:off x="4636008" y="4937760"/>
             <a:ext cx="3108960" cy="548640"/>
           </a:xfrm>
           <a:prstGeom prst="rect">
@@ -3438,11 +3438,11 @@
         <p:spPr>
           <a:xfrm>
             <a:off x="8266176" y="2468880"/>
-            <a:ext cx="3566160" cy="2971800"/>
+            <a:ext cx="3566160" cy="3200400"/>
           </a:xfrm>
           <a:prstGeom prst="roundRect">
             <a:avLst>
-              <a:gd name="adj" fmla="val 3077"/>
+              <a:gd name="adj" fmla="val 2857"/>
             </a:avLst>
           </a:prstGeom>
           <a:solidFill>
@@ -3493,7 +3493,7 @@
                 <a:ea typeface="Calibri" pitchFamily="34" charset="-122"/>
                 <a:cs typeface="Calibri" pitchFamily="34" charset="-120"/>
               </a:rPr>
-              <a:t>License our engines (DMRV, rules-as-code clearances, incentive verification) to other states and enterprises</a:t>
+              <a:t>Identify a few needs that repeat across our projects and build them into products or platforms</a:t>
             </a:r>
             <a:endParaRPr lang="en-US" sz="1400" dirty="0"/>
           </a:p>
@@ -3514,7 +3514,7 @@
                 <a:ea typeface="Calibri" pitchFamily="34" charset="-122"/>
                 <a:cs typeface="Calibri" pitchFamily="34" charset="-120"/>
               </a:rPr>
-              <a:t>SaaS subscriptions for industry compliance</a:t>
+              <a:t>Subscription and licence revenue that keeps the business sustainable</a:t>
             </a:r>
             <a:endParaRPr lang="en-US" sz="1400" dirty="0"/>
           </a:p>
@@ -3549,7 +3549,7 @@
         </p:nvSpPr>
         <p:spPr>
           <a:xfrm>
-            <a:off x="8494776" y="4709160"/>
+            <a:off x="8494776" y="4937760"/>
             <a:ext cx="3108960" cy="548640"/>
           </a:xfrm>
           <a:prstGeom prst="roundRect">
@@ -3576,7 +3576,7 @@
         </p:nvSpPr>
         <p:spPr>
           <a:xfrm>
-            <a:off x="8494776" y="4709160"/>
+            <a:off x="8494776" y="4937760"/>
             <a:ext cx="3108960" cy="548640"/>
           </a:xfrm>
           <a:prstGeom prst="rect">
@@ -3601,7 +3601,7 @@
                 <a:ea typeface="Calibri" pitchFamily="34" charset="-122"/>
                 <a:cs typeface="Calibri" pitchFamily="34" charset="-120"/>
               </a:rPr>
-              <a:t>Target: 40%+ revenue from products</a:t>
+              <a:t>Target: 35%+ revenue from products</a:t>
             </a:r>
             <a:endParaRPr lang="en-US" sz="1400" dirty="0"/>
           </a:p>
@@ -3615,7 +3615,7 @@
         </p:nvSpPr>
         <p:spPr>
           <a:xfrm>
-            <a:off x="548640" y="5760720"/>
+            <a:off x="548640" y="5943600"/>
             <a:ext cx="11064240" cy="548640"/>
           </a:xfrm>
           <a:prstGeom prst="rect">

</xml_diff>

<commit_message>
docs: change social commitment to 1% revenue floor with profit step-up
Replace the flat 2%-of-revenue pledge with 1% of total revenue from
year one, rising once profitable to 2% of revenue or 10% of net
profit, whichever is higher. Clarify the fund is based on total
company revenue and independent of any contract.

Co-Authored-By: Claude Opus 5.5 <noreply@anthropic.com>
Claude-Session: https://claude.ai/code/session_01KWMWvQ91DXYjjkruj1UFSM
</commit_message>
<xml_diff>
--- a/docs/wb-ice-proposal-2026/Company_Vision_Goals.pptx
+++ b/docs/wb-ice-proposal-2026/Company_Vision_Goals.pptx
@@ -1180,7 +1180,7 @@
           <a:p>
             <a:r>
               <a:rPr lang="en-US" dirty="0"/>
-              <a:t>The 2% figure is a proposal and can be adjusted. Keeping the fund board-governed and separate from procurement protects both the company and every partner who supports it.</a:t>
+              <a:t>The 1% floor keeps the promise real in lean early years; the step-up to 2% of revenue or 10% of net profit (whichever is higher) grows with the company. Figures are proposals to confirm with our chartered accountant (80G structuring). Keeping the fund board-governed and separate from procurement protects both the company and every partner who supports it.</a:t>
             </a:r>
             <a:endParaRPr lang="en-US" dirty="0"/>
           </a:p>
@@ -3871,7 +3871,7 @@
                 <a:ea typeface="Cambria" pitchFamily="34" charset="-122"/>
                 <a:cs typeface="Cambria" pitchFamily="34" charset="-120"/>
               </a:rPr>
-              <a:t>2%</a:t>
+              <a:t>1%</a:t>
             </a:r>
             <a:endParaRPr lang="en-US" sz="6400" dirty="0"/>
           </a:p>
@@ -3885,7 +3885,7 @@
         </p:nvSpPr>
         <p:spPr>
           <a:xfrm>
-            <a:off x="8503920" y="1965960"/>
+            <a:off x="8503920" y="1920240"/>
             <a:ext cx="2770632" cy="822960"/>
           </a:xfrm>
           <a:prstGeom prst="rect">
@@ -3910,7 +3910,7 @@
                 <a:ea typeface="Calibri" pitchFamily="34" charset="-122"/>
                 <a:cs typeface="Calibri" pitchFamily="34" charset="-120"/>
               </a:rPr>
-              <a:t>of annual revenue, from year one, to a Bengal Social Impact Fund</a:t>
+              <a:t>of total annual revenue from year one, to a Bengal Social Impact Fund</a:t>
             </a:r>
             <a:endParaRPr lang="en-US" sz="1600" dirty="0"/>
           </a:p>
@@ -3918,14 +3918,41 @@
       </p:sp>
       <p:sp>
         <p:nvSpPr>
-          <p:cNvPr id="9" name="Text 6"/>
+          <p:cNvPr id="9" name="Shape 6"/>
+          <p:cNvSpPr/>
+          <p:nvPr/>
+        </p:nvSpPr>
+        <p:spPr>
+          <a:xfrm>
+            <a:off x="6858000" y="2880360"/>
+            <a:ext cx="4416552" cy="685800"/>
+          </a:xfrm>
+          <a:prstGeom prst="roundRect">
+            <a:avLst>
+              <a:gd name="adj" fmla="val 10667"/>
+            </a:avLst>
+          </a:prstGeom>
+          <a:solidFill>
+            <a:srgbClr val="15293F"/>
+          </a:solidFill>
+          <a:ln w="12700">
+            <a:solidFill>
+              <a:srgbClr val="15293F"/>
+            </a:solidFill>
+            <a:prstDash val="solid"/>
+          </a:ln>
+        </p:spPr>
+      </p:sp>
+      <p:sp>
+        <p:nvSpPr>
+          <p:cNvPr id="10" name="Text 7"/>
           <p:cNvSpPr txBox="1"/>
           <p:nvPr/>
         </p:nvSpPr>
         <p:spPr>
           <a:xfrm>
-            <a:off x="6858000" y="3017520"/>
-            <a:ext cx="4416552" cy="3017520"/>
+            <a:off x="7040880" y="2880360"/>
+            <a:ext cx="4050792" cy="685800"/>
           </a:xfrm>
           <a:prstGeom prst="rect">
             <a:avLst/>
@@ -3934,18 +3961,85 @@
           <a:ln/>
         </p:spPr>
         <p:txBody>
+          <a:bodyPr wrap="square" lIns="0" tIns="0" rIns="0" bIns="0" rtlCol="0" anchor="ctr"/>
+          <a:lstStyle/>
+          <a:p>
+            <a:pPr indent="0" marL="0">
+              <a:buNone/>
+            </a:pPr>
+            <a:r>
+              <a:rPr lang="en-US" sz="1400" dirty="0">
+                <a:solidFill>
+                  <a:srgbClr val="DCE6F2"/>
+                </a:solidFill>
+                <a:latin typeface="Calibri" pitchFamily="34" charset="0"/>
+                <a:ea typeface="Calibri" pitchFamily="34" charset="-122"/>
+                <a:cs typeface="Calibri" pitchFamily="34" charset="-120"/>
+              </a:rPr>
+              <a:t>Once profitable, rising to </a:t>
+            </a:r>
+            <a:pPr indent="0" marL="0">
+              <a:buNone/>
+            </a:pPr>
+            <a:r>
+              <a:rPr lang="en-US" sz="1400" b="1" dirty="0">
+                <a:solidFill>
+                  <a:srgbClr val="FFFFFF"/>
+                </a:solidFill>
+                <a:latin typeface="Calibri" pitchFamily="34" charset="0"/>
+                <a:ea typeface="Calibri" pitchFamily="34" charset="-122"/>
+                <a:cs typeface="Calibri" pitchFamily="34" charset="-120"/>
+              </a:rPr>
+              <a:t>2% of revenue or 10% of net profit</a:t>
+            </a:r>
+            <a:pPr indent="0" marL="0">
+              <a:buNone/>
+            </a:pPr>
+            <a:r>
+              <a:rPr lang="en-US" sz="1400" dirty="0">
+                <a:solidFill>
+                  <a:srgbClr val="DCE6F2"/>
+                </a:solidFill>
+                <a:latin typeface="Calibri" pitchFamily="34" charset="0"/>
+                <a:ea typeface="Calibri" pitchFamily="34" charset="-122"/>
+                <a:cs typeface="Calibri" pitchFamily="34" charset="-120"/>
+              </a:rPr>
+              <a:t>, whichever is higher</a:t>
+            </a:r>
+            <a:endParaRPr lang="en-US" sz="1400" dirty="0"/>
+          </a:p>
+        </p:txBody>
+      </p:sp>
+      <p:sp>
+        <p:nvSpPr>
+          <p:cNvPr id="11" name="Text 8"/>
+          <p:cNvSpPr txBox="1"/>
+          <p:nvPr/>
+        </p:nvSpPr>
+        <p:spPr>
+          <a:xfrm>
+            <a:off x="6858000" y="3749040"/>
+            <a:ext cx="4416552" cy="2377440"/>
+          </a:xfrm>
+          <a:prstGeom prst="rect">
+            <a:avLst/>
+          </a:prstGeom>
+          <a:noFill/>
+          <a:ln/>
+        </p:spPr>
+        <p:txBody>
           <a:bodyPr wrap="square" lIns="0" tIns="0" rIns="0" bIns="0" rtlCol="0" anchor="t"/>
           <a:lstStyle/>
           <a:p>
             <a:pPr marL="177800" indent="-177800">
               <a:spcAft>
-                <a:spcPts val="800"/>
+                <a:spcPts val="600"/>
               </a:spcAft>
               <a:buSzPct val="100000"/>
               <a:buChar char="•"/>
             </a:pPr>
             <a:r>
-              <a:rPr lang="en-US" sz="1400" b="1" dirty="0">
+              <a:rPr lang="en-US" sz="1300" b="1" dirty="0">
                 <a:solidFill>
                   <a:srgbClr val="F6C27A"/>
                 </a:solidFill>
@@ -3957,12 +4051,12 @@
             </a:r>
             <a:pPr indent="0" marL="0">
               <a:spcAft>
-                <a:spcPts val="800"/>
+                <a:spcPts val="600"/>
               </a:spcAft>
               <a:buNone/>
             </a:pPr>
             <a:r>
-              <a:rPr lang="en-US" sz="1400" dirty="0">
+              <a:rPr lang="en-US" sz="1300" dirty="0">
                 <a:solidFill>
                   <a:srgbClr val="DCE6F2"/>
                 </a:solidFill>
@@ -3972,18 +4066,18 @@
               </a:rPr>
               <a:t>digital skills for youth, artisan and MSME training, women entrepreneurs, STEM labs in schools.</a:t>
             </a:r>
-            <a:endParaRPr lang="en-US" sz="1400" dirty="0"/>
+            <a:endParaRPr lang="en-US" sz="1300" dirty="0"/>
           </a:p>
           <a:p>
             <a:pPr marL="177800" indent="-177800">
               <a:spcAft>
-                <a:spcPts val="800"/>
+                <a:spcPts val="600"/>
               </a:spcAft>
               <a:buSzPct val="100000"/>
               <a:buChar char="•"/>
             </a:pPr>
             <a:r>
-              <a:rPr lang="en-US" sz="1400" b="1" dirty="0">
+              <a:rPr lang="en-US" sz="1300" b="1" dirty="0">
                 <a:solidFill>
                   <a:srgbClr val="F6C27A"/>
                 </a:solidFill>
@@ -3995,12 +4089,12 @@
             </a:r>
             <a:pPr indent="0" marL="0">
               <a:spcAft>
-                <a:spcPts val="800"/>
+                <a:spcPts val="600"/>
               </a:spcAft>
               <a:buNone/>
             </a:pPr>
             <a:r>
-              <a:rPr lang="en-US" sz="1400" dirty="0">
+              <a:rPr lang="en-US" sz="1300" dirty="0">
                 <a:solidFill>
                   <a:srgbClr val="DCE6F2"/>
                 </a:solidFill>
@@ -4010,18 +4104,18 @@
               </a:rPr>
               <a:t>public representatives and local bodies can propose programmes for their areas.</a:t>
             </a:r>
-            <a:endParaRPr lang="en-US" sz="1400" dirty="0"/>
+            <a:endParaRPr lang="en-US" sz="1300" dirty="0"/>
           </a:p>
           <a:p>
             <a:pPr marL="177800" indent="-177800">
               <a:spcAft>
-                <a:spcPts val="800"/>
+                <a:spcPts val="600"/>
               </a:spcAft>
               <a:buSzPct val="100000"/>
               <a:buChar char="•"/>
             </a:pPr>
             <a:r>
-              <a:rPr lang="en-US" sz="1400" b="1" dirty="0">
+              <a:rPr lang="en-US" sz="1300" b="1" dirty="0">
                 <a:solidFill>
                   <a:srgbClr val="F6C27A"/>
                 </a:solidFill>
@@ -4033,12 +4127,12 @@
             </a:r>
             <a:pPr indent="0" marL="0">
               <a:spcAft>
-                <a:spcPts val="800"/>
+                <a:spcPts val="600"/>
               </a:spcAft>
               <a:buNone/>
             </a:pPr>
             <a:r>
-              <a:rPr lang="en-US" sz="1400" dirty="0">
+              <a:rPr lang="en-US" sz="1300" dirty="0">
                 <a:solidFill>
                   <a:srgbClr val="DCE6F2"/>
                 </a:solidFill>
@@ -4046,20 +4140,20 @@
                 <a:ea typeface="Calibri" pitchFamily="34" charset="-122"/>
                 <a:cs typeface="Calibri" pitchFamily="34" charset="-120"/>
               </a:rPr>
-              <a:t>approved by our Board under Companies Act Schedule VII areas, with an annual public report.</a:t>
-            </a:r>
-            <a:endParaRPr lang="en-US" sz="1400" dirty="0"/>
+              <a:t>approved by our Board in Schedule VII areas, with an annual public report.</a:t>
+            </a:r>
+            <a:endParaRPr lang="en-US" sz="1300" dirty="0"/>
           </a:p>
           <a:p>
             <a:pPr marL="177800" indent="-177800">
               <a:spcAft>
-                <a:spcPts val="800"/>
+                <a:spcPts val="600"/>
               </a:spcAft>
               <a:buSzPct val="100000"/>
               <a:buChar char="•"/>
             </a:pPr>
             <a:r>
-              <a:rPr lang="en-US" sz="1400" b="1" dirty="0">
+              <a:rPr lang="en-US" sz="1300" b="1" dirty="0">
                 <a:solidFill>
                   <a:srgbClr val="F6C27A"/>
                 </a:solidFill>
@@ -4071,12 +4165,12 @@
             </a:r>
             <a:pPr indent="0" marL="0">
               <a:spcAft>
-                <a:spcPts val="800"/>
+                <a:spcPts val="600"/>
               </a:spcAft>
               <a:buNone/>
             </a:pPr>
             <a:r>
-              <a:rPr lang="en-US" sz="1400" dirty="0">
+              <a:rPr lang="en-US" sz="1300" dirty="0">
                 <a:solidFill>
                   <a:srgbClr val="DCE6F2"/>
                 </a:solidFill>
@@ -4084,9 +4178,9 @@
                 <a:ea typeface="Calibri" pitchFamily="34" charset="-122"/>
                 <a:cs typeface="Calibri" pitchFamily="34" charset="-120"/>
               </a:rPr>
-              <a:t>the fund is independent of any contract. We win work only through open, transparent procurement.</a:t>
-            </a:r>
-            <a:endParaRPr lang="en-US" sz="1400" dirty="0"/>
+              <a:t>based on total company revenue and independent of any contract. We win work only through open procurement.</a:t>
+            </a:r>
+            <a:endParaRPr lang="en-US" sz="1300" dirty="0"/>
           </a:p>
         </p:txBody>
       </p:sp>

</xml_diff>

<commit_message>
docs: brand proposal and slides as Kirnova Technologies
Replace the [Company Name] placeholder with Kirnova Technologies across
the booklet (cover, footer, metadata) and slides, and add the name's
meaning (kiran + nova: a new ray of light) to the vision slide.

Co-Authored-By: Claude Opus 5.5 <noreply@anthropic.com>
Claude-Session: https://claude.ai/code/session_01KWMWvQ91DXYjjkruj1UFSM
</commit_message>
<xml_diff>
--- a/docs/wb-ice-proposal-2026/Company_Vision_Goals.pptx
+++ b/docs/wb-ice-proposal-2026/Company_Vision_Goals.pptx
@@ -1562,7 +1562,7 @@
         <p:spPr>
           <a:xfrm>
             <a:off x="548640" y="411480"/>
-            <a:ext cx="7315200" cy="320040"/>
+            <a:ext cx="5029200" cy="320040"/>
           </a:xfrm>
           <a:prstGeom prst="rect">
             <a:avLst/>
@@ -1586,7 +1586,7 @@
                 <a:ea typeface="Calibri" pitchFamily="34" charset="-122"/>
                 <a:cs typeface="Calibri" pitchFamily="34" charset="-120"/>
               </a:rPr>
-              <a:t>[COMPANY NAME]</a:t>
+              <a:t>KIRNOVA TECHNOLOGIES</a:t>
             </a:r>
             <a:endParaRPr lang="en-US" sz="1300" dirty="0"/>
           </a:p>
@@ -1595,6 +1595,73 @@
       <p:sp>
         <p:nvSpPr>
           <p:cNvPr id="3" name="Text 1"/>
+          <p:cNvSpPr txBox="1"/>
+          <p:nvPr/>
+        </p:nvSpPr>
+        <p:spPr>
+          <a:xfrm>
+            <a:off x="5669280" y="411480"/>
+            <a:ext cx="5971032" cy="320040"/>
+          </a:xfrm>
+          <a:prstGeom prst="rect">
+            <a:avLst/>
+          </a:prstGeom>
+          <a:noFill/>
+          <a:ln/>
+        </p:spPr>
+        <p:txBody>
+          <a:bodyPr wrap="square" lIns="0" tIns="0" rIns="0" bIns="0" rtlCol="0" anchor="t"/>
+          <a:lstStyle/>
+          <a:p>
+            <a:pPr algn="r" indent="0" marL="0">
+              <a:buNone/>
+            </a:pPr>
+            <a:r>
+              <a:rPr lang="en-US" sz="1300" b="1" dirty="0">
+                <a:solidFill>
+                  <a:srgbClr val="FFFFFF"/>
+                </a:solidFill>
+                <a:latin typeface="Calibri" pitchFamily="34" charset="0"/>
+                <a:ea typeface="Calibri" pitchFamily="34" charset="-122"/>
+                <a:cs typeface="Calibri" pitchFamily="34" charset="-120"/>
+              </a:rPr>
+              <a:t>Kirnova</a:t>
+            </a:r>
+            <a:pPr algn="r" indent="0" marL="0">
+              <a:buNone/>
+            </a:pPr>
+            <a:r>
+              <a:rPr lang="en-US" sz="1300" dirty="0">
+                <a:solidFill>
+                  <a:srgbClr val="DCE6F2"/>
+                </a:solidFill>
+                <a:latin typeface="Calibri" pitchFamily="34" charset="0"/>
+                <a:ea typeface="Calibri" pitchFamily="34" charset="-122"/>
+                <a:cs typeface="Calibri" pitchFamily="34" charset="-120"/>
+              </a:rPr>
+              <a:t> = kiran (a ray of light) + nova (new):  </a:t>
+            </a:r>
+            <a:pPr algn="r" indent="0" marL="0">
+              <a:buNone/>
+            </a:pPr>
+            <a:r>
+              <a:rPr lang="en-US" sz="1300" i="1" dirty="0">
+                <a:solidFill>
+                  <a:srgbClr val="F6C27A"/>
+                </a:solidFill>
+                <a:latin typeface="Calibri" pitchFamily="34" charset="0"/>
+                <a:ea typeface="Calibri" pitchFamily="34" charset="-122"/>
+                <a:cs typeface="Calibri" pitchFamily="34" charset="-120"/>
+              </a:rPr>
+              <a:t>a new ray of light</a:t>
+            </a:r>
+            <a:endParaRPr lang="en-US" sz="1300" dirty="0"/>
+          </a:p>
+        </p:txBody>
+      </p:sp>
+      <p:sp>
+        <p:nvSpPr>
+          <p:cNvPr id="4" name="Text 2"/>
           <p:cNvSpPr txBox="1"/>
           <p:nvPr/>
         </p:nvSpPr>
@@ -1633,7 +1700,7 @@
       </p:sp>
       <p:sp>
         <p:nvSpPr>
-          <p:cNvPr id="4" name="Text 2"/>
+          <p:cNvPr id="5" name="Text 3"/>
           <p:cNvSpPr txBox="1"/>
           <p:nvPr/>
         </p:nvSpPr>
@@ -1672,7 +1739,7 @@
       </p:sp>
       <p:sp>
         <p:nvSpPr>
-          <p:cNvPr id="5" name="Shape 3"/>
+          <p:cNvPr id="6" name="Shape 4"/>
           <p:cNvSpPr/>
           <p:nvPr/>
         </p:nvSpPr>
@@ -1699,7 +1766,7 @@
       </p:sp>
       <p:sp>
         <p:nvSpPr>
-          <p:cNvPr id="6" name="Shape 4"/>
+          <p:cNvPr id="7" name="Shape 5"/>
           <p:cNvSpPr/>
           <p:nvPr/>
         </p:nvSpPr>
@@ -1724,7 +1791,7 @@
       </p:sp>
       <p:sp>
         <p:nvSpPr>
-          <p:cNvPr id="7" name="Text 5"/>
+          <p:cNvPr id="8" name="Text 6"/>
           <p:cNvSpPr txBox="1"/>
           <p:nvPr/>
         </p:nvSpPr>
@@ -1763,7 +1830,7 @@
       </p:sp>
       <p:sp>
         <p:nvSpPr>
-          <p:cNvPr id="8" name="Text 6"/>
+          <p:cNvPr id="9" name="Text 7"/>
           <p:cNvSpPr txBox="1"/>
           <p:nvPr/>
         </p:nvSpPr>
@@ -1802,7 +1869,7 @@
       </p:sp>
       <p:sp>
         <p:nvSpPr>
-          <p:cNvPr id="9" name="Text 7"/>
+          <p:cNvPr id="10" name="Text 8"/>
           <p:cNvSpPr txBox="1"/>
           <p:nvPr/>
         </p:nvSpPr>
@@ -1844,7 +1911,7 @@
       </p:sp>
       <p:sp>
         <p:nvSpPr>
-          <p:cNvPr id="10" name="Shape 8"/>
+          <p:cNvPr id="11" name="Shape 9"/>
           <p:cNvSpPr/>
           <p:nvPr/>
         </p:nvSpPr>
@@ -1871,7 +1938,7 @@
       </p:sp>
       <p:sp>
         <p:nvSpPr>
-          <p:cNvPr id="11" name="Shape 9"/>
+          <p:cNvPr id="12" name="Shape 10"/>
           <p:cNvSpPr/>
           <p:nvPr/>
         </p:nvSpPr>
@@ -1896,7 +1963,7 @@
       </p:sp>
       <p:sp>
         <p:nvSpPr>
-          <p:cNvPr id="12" name="Text 10"/>
+          <p:cNvPr id="13" name="Text 11"/>
           <p:cNvSpPr txBox="1"/>
           <p:nvPr/>
         </p:nvSpPr>
@@ -1935,7 +2002,7 @@
       </p:sp>
       <p:sp>
         <p:nvSpPr>
-          <p:cNvPr id="13" name="Text 11"/>
+          <p:cNvPr id="14" name="Text 12"/>
           <p:cNvSpPr txBox="1"/>
           <p:nvPr/>
         </p:nvSpPr>
@@ -1974,7 +2041,7 @@
       </p:sp>
       <p:sp>
         <p:nvSpPr>
-          <p:cNvPr id="14" name="Text 12"/>
+          <p:cNvPr id="15" name="Text 13"/>
           <p:cNvSpPr txBox="1"/>
           <p:nvPr/>
         </p:nvSpPr>
@@ -2186,7 +2253,7 @@
       </p:sp>
       <p:sp>
         <p:nvSpPr>
-          <p:cNvPr id="15" name="Shape 13"/>
+          <p:cNvPr id="16" name="Shape 14"/>
           <p:cNvSpPr/>
           <p:nvPr/>
         </p:nvSpPr>
@@ -2213,7 +2280,7 @@
       </p:sp>
       <p:sp>
         <p:nvSpPr>
-          <p:cNvPr id="16" name="Text 14"/>
+          <p:cNvPr id="17" name="Text 15"/>
           <p:cNvSpPr txBox="1"/>
           <p:nvPr/>
         </p:nvSpPr>
@@ -2252,7 +2319,7 @@
       </p:sp>
       <p:sp>
         <p:nvSpPr>
-          <p:cNvPr id="17" name="Shape 15"/>
+          <p:cNvPr id="18" name="Shape 16"/>
           <p:cNvSpPr/>
           <p:nvPr/>
         </p:nvSpPr>
@@ -2279,7 +2346,7 @@
       </p:sp>
       <p:sp>
         <p:nvSpPr>
-          <p:cNvPr id="18" name="Text 16"/>
+          <p:cNvPr id="19" name="Text 17"/>
           <p:cNvSpPr txBox="1"/>
           <p:nvPr/>
         </p:nvSpPr>
@@ -2318,7 +2385,7 @@
       </p:sp>
       <p:sp>
         <p:nvSpPr>
-          <p:cNvPr id="19" name="Shape 17"/>
+          <p:cNvPr id="20" name="Shape 18"/>
           <p:cNvSpPr/>
           <p:nvPr/>
         </p:nvSpPr>
@@ -2345,7 +2412,7 @@
       </p:sp>
       <p:sp>
         <p:nvSpPr>
-          <p:cNvPr id="20" name="Text 18"/>
+          <p:cNvPr id="21" name="Text 19"/>
           <p:cNvSpPr txBox="1"/>
           <p:nvPr/>
         </p:nvSpPr>
@@ -2384,7 +2451,7 @@
       </p:sp>
       <p:sp>
         <p:nvSpPr>
-          <p:cNvPr id="21" name="Shape 19"/>
+          <p:cNvPr id="22" name="Shape 20"/>
           <p:cNvSpPr/>
           <p:nvPr/>
         </p:nvSpPr>
@@ -2411,7 +2478,7 @@
       </p:sp>
       <p:sp>
         <p:nvSpPr>
-          <p:cNvPr id="22" name="Text 20"/>
+          <p:cNvPr id="23" name="Text 21"/>
           <p:cNvSpPr txBox="1"/>
           <p:nvPr/>
         </p:nvSpPr>
@@ -2450,7 +2517,7 @@
       </p:sp>
       <p:sp>
         <p:nvSpPr>
-          <p:cNvPr id="23" name="Shape 21"/>
+          <p:cNvPr id="24" name="Shape 22"/>
           <p:cNvSpPr/>
           <p:nvPr/>
         </p:nvSpPr>
@@ -2477,7 +2544,7 @@
       </p:sp>
       <p:sp>
         <p:nvSpPr>
-          <p:cNvPr id="24" name="Text 22"/>
+          <p:cNvPr id="25" name="Text 23"/>
           <p:cNvSpPr txBox="1"/>
           <p:nvPr/>
         </p:nvSpPr>

</xml_diff>